<commit_message>
submission: set the deck's document subject and refresh its image descriptions
</commit_message>
<xml_diff>
--- a/submission/TeamMausam_SIH2026_PS26076.pptx
+++ b/submission/TeamMausam_SIH2026_PS26076.pptx
@@ -2156,7 +2156,7 @@
       </p:sp>
       <p:pic>
         <p:nvPicPr>
-          <p:cNvPr id="26" name="Image 0" descr="/Users/anushka/Downloads/team_mausam_sih_2026/docs/screenshots/c1_step02_morning_0730_parent_commuter.png">    </p:cNvPr>
+          <p:cNvPr id="26" name="Image 0" descr="Morning home screen for a parent and commuter">    </p:cNvPr>
           <p:cNvPicPr>
             <a:picLocks noChangeAspect="1"/>
           </p:cNvPicPr>
@@ -3000,7 +3000,7 @@
       </p:sp>
       <p:pic>
         <p:nvPicPr>
-          <p:cNvPr id="23" name="Image 0" descr="/Users/anushka/Downloads/team_mausam_sih_2026/docs/screenshots/c1_step03_persona_parent.png">    </p:cNvPr>
+          <p:cNvPr id="23" name="Image 0" descr="Parent home screen">    </p:cNvPr>
           <p:cNvPicPr>
             <a:picLocks noChangeAspect="1"/>
           </p:cNvPicPr>
@@ -3063,7 +3063,7 @@
       </p:sp>
       <p:pic>
         <p:nvPicPr>
-          <p:cNvPr id="25" name="Image 1" descr="/Users/anushka/Downloads/team_mausam_sih_2026/docs/screenshots/c1_step03_persona_fitness.png">    </p:cNvPr>
+          <p:cNvPr id="25" name="Image 1" descr="Fitness home screen">    </p:cNvPr>
           <p:cNvPicPr>
             <a:picLocks noChangeAspect="1"/>
           </p:cNvPicPr>
@@ -3126,7 +3126,7 @@
       </p:sp>
       <p:pic>
         <p:nvPicPr>
-          <p:cNvPr id="27" name="Image 2" descr="/Users/anushka/Downloads/team_mausam_sih_2026/docs/screenshots/c1_step03_persona_health.png">    </p:cNvPr>
+          <p:cNvPr id="27" name="Image 2" descr="Health home screen">    </p:cNvPr>
           <p:cNvPicPr>
             <a:picLocks noChangeAspect="1"/>
           </p:cNvPicPr>
@@ -9179,7 +9179,7 @@
       </p:sp>
       <p:pic>
         <p:nvPicPr>
-          <p:cNvPr id="22" name="Image 0" descr="/Users/anushka/Downloads/team_mausam_sih_2026/docs/screenshots/c1_step05_ws_before.png">    </p:cNvPr>
+          <p:cNvPr id="22" name="Image 0" descr="Feed before the warning is pushed">    </p:cNvPr>
           <p:cNvPicPr>
             <a:picLocks noChangeAspect="1"/>
           </p:cNvPicPr>
@@ -9242,7 +9242,7 @@
       </p:sp>
       <p:pic>
         <p:nvPicPr>
-          <p:cNvPr id="24" name="Image 1" descr="/Users/anushka/Downloads/team_mausam_sih_2026/docs/screenshots/c1_step05_ws_rerank.png">    </p:cNvPr>
+          <p:cNvPr id="24" name="Image 1" descr="Feed after the warning, re-ranked">    </p:cNvPr>
           <p:cNvPicPr>
             <a:picLocks noChangeAspect="1"/>
           </p:cNvPicPr>
@@ -9305,7 +9305,7 @@
       </p:sp>
       <p:pic>
         <p:nvPicPr>
-          <p:cNvPr id="26" name="Image 2" descr="/Users/anushka/Downloads/team_mausam_sih_2026/docs/screenshots/c1_step08_hindi_home.png">    </p:cNvPr>
+          <p:cNvPr id="26" name="Image 2" descr="Home screen in Hindi">    </p:cNvPr>
           <p:cNvPicPr>
             <a:picLocks noChangeAspect="1"/>
           </p:cNvPicPr>
@@ -9870,7 +9870,7 @@
                 <a:ea typeface="Calibri" pitchFamily="34" charset="-122"/>
                 <a:cs typeface="Calibri" pitchFamily="34" charset="-120"/>
               </a:rPr>
-              <a:t>Team Mausam · SIH 2026 · PS 26076 (MoES / IMD) · Software · Smart Automation   |   github.com/Shreyansh303/team_mausam_sih_2026   |   Evidence: docs/QA_REPORT.md · Pitch: docs/08_PITCH.md</a:t>
+              <a:t>Team Mausam · SIH 2026 · PS 26076 (MoES / IMD) · Software · Smart Automation   |   github.com/Shreyansh303/team_mausam_sih_2026   |   Evidence: docs/QA_REPORT.md · Pitch: docs/07_PITCH.md</a:t>
             </a:r>
             <a:endParaRPr lang="en-US" sz="850" dirty="0"/>
           </a:p>

</xml_diff>